<commit_message>
Refresh every number across the docs and the deck
Runs 96 to 137, success 97.8% to 98.5%, policy evaluations 9,752 to 13,822,
Workbench 177 to 247 open with 2 resolved. A figure quoted on camera that the
app does not show is the one thing a judge will catch.

Also documents what was built today and had appeared nowhere: the per-ticket
decision path and why it exists, the 3.0% auto-resolution rate with the
missing-article cause behind seventeen of the blocks, and the Workbench classes.

The demo script gains an honest answer to "does it actually resolve tickets
automatically" — 3% that traces to a run beats a larger number that does not —
and to "why one ticket at a time", which a judge will ask once they understand
the architecture.

Co-Authored-By: Claude Opus 5 <noreply@anthropic.com>
</commit_message>
<xml_diff>
--- a/docs/Service-Desk-Command-Center.pptx
+++ b/docs/Service-Desk-Command-Center.pptx
@@ -6848,7 +6848,7 @@
                 <a:ea typeface="Calibri" pitchFamily="34" charset="-122"/>
                 <a:cs typeface="Calibri" pitchFamily="34" charset="-120"/>
               </a:rPr>
-              <a:t>9,752</a:t>
+              <a:t>13,822</a:t>
             </a:r>
             <a:endParaRPr lang="en-US" sz="5200" dirty="0"/>
           </a:p>
@@ -8565,7 +8565,7 @@
                 <a:ea typeface="Calibri" pitchFamily="34" charset="-122"/>
                 <a:cs typeface="Calibri" pitchFamily="34" charset="-120"/>
               </a:rPr>
-              <a:t>96</a:t>
+              <a:t>137</a:t>
             </a:r>
             <a:endParaRPr lang="en-US" sz="5200" dirty="0"/>
           </a:p>
@@ -8604,7 +8604,7 @@
                 <a:ea typeface="Calibri" pitchFamily="34" charset="-122"/>
                 <a:cs typeface="Calibri" pitchFamily="34" charset="-120"/>
               </a:rPr>
-              <a:t>AGENT RUNS · 97.8% SUCCESS</a:t>
+              <a:t>AGENT RUNS · 98.5% SUCCESS</a:t>
             </a:r>
             <a:endParaRPr lang="en-US" sz="1050" dirty="0"/>
           </a:p>

</xml_diff>

<commit_message>
Fix the two deck figures the rebuild missed
The deflection tile still read 380 preventable and the queue tile 176 waiting on
a human. Both are slides a judge reads off the screen, so a stale figure there
is the one that gets quoted back.

Co-Authored-By: Claude Opus 5 <noreply@anthropic.com>
</commit_message>
<xml_diff>
--- a/docs/Service-Desk-Command-Center.pptx
+++ b/docs/Service-Desk-Command-Center.pptx
@@ -1013,7 +1013,7 @@
           <a:p>
             <a:r>
               <a:rPr lang="en-US" dirty="0"/>
-              <a:t>End on 380. Do not add anything after this.</a:t>
+              <a:t>End on 417. Do not add anything after this.</a:t>
             </a:r>
             <a:endParaRPr lang="en-US" dirty="0"/>
           </a:p>
@@ -2313,7 +2313,7 @@
                 <a:ea typeface="Calibri" pitchFamily="34" charset="-122"/>
                 <a:cs typeface="Calibri" pitchFamily="34" charset="-120"/>
               </a:rPr>
-              <a:t>380</a:t>
+              <a:t>417</a:t>
             </a:r>
             <a:endParaRPr lang="en-US" sz="5200" dirty="0"/>
           </a:p>
@@ -3416,7 +3416,7 @@
                 <a:ea typeface="Calibri" pitchFamily="34" charset="-122"/>
                 <a:cs typeface="Calibri" pitchFamily="34" charset="-120"/>
               </a:rPr>
-              <a:t>380</a:t>
+              <a:t>417</a:t>
             </a:r>
             <a:endParaRPr lang="en-US" sz="5200" dirty="0"/>
           </a:p>
@@ -5599,7 +5599,7 @@
                 <a:ea typeface="Calibri" pitchFamily="34" charset="-122"/>
                 <a:cs typeface="Calibri" pitchFamily="34" charset="-120"/>
               </a:rPr>
-              <a:t>380</a:t>
+              <a:t>417</a:t>
             </a:r>
             <a:endParaRPr lang="en-US" sz="5000" dirty="0"/>
           </a:p>
@@ -7004,7 +7004,7 @@
                 <a:ea typeface="Calibri" pitchFamily="34" charset="-122"/>
                 <a:cs typeface="Calibri" pitchFamily="34" charset="-120"/>
               </a:rPr>
-              <a:t>176</a:t>
+              <a:t>36</a:t>
             </a:r>
             <a:endParaRPr lang="en-US" sz="5200" dirty="0"/>
           </a:p>

</xml_diff>